<commit_message>
docs: reconcile WP0 and WP1 evidence with v2.6
</commit_message>
<xml_diff>
--- a/docs/km-modernization/progress/presentations/AI-KM-Weekly-2026-W33.pptx
+++ b/docs/km-modernization/progress/presentations/AI-KM-Weekly-2026-W33.pptx
@@ -1726,7 +1726,7 @@
                 <a:ea typeface="Microsoft JhengHei" pitchFamily="34" charset="-122"/>
                 <a:cs typeface="Microsoft JhengHei" pitchFamily="34" charset="-120"/>
               </a:rPr>
-              <a:t>2026-W33｜進度管理基準週</a:t>
+              <a:t>2026-W33｜v2.6 進度管理基準週</a:t>
             </a:r>
             <a:endParaRPr lang="en-US" sz="2000" dirty="0"/>
           </a:p>
@@ -1767,7 +1767,7 @@
                 <a:ea typeface="Microsoft JhengHei" pitchFamily="34" charset="-122"/>
                 <a:cs typeface="Microsoft JhengHei" pitchFamily="34" charset="-120"/>
               </a:rPr>
-              <a:t>Phase 0 正式化基座</a:t>
+              <a:t>Phase 1 AI KM MVP（Production Ready）</a:t>
             </a:r>
             <a:endParaRPr lang="en-US" sz="1800" dirty="0"/>
           </a:p>
@@ -2034,7 +2034,7 @@
                 <a:ea typeface="Microsoft JhengHei" pitchFamily="34" charset="-122"/>
                 <a:cs typeface="Microsoft JhengHei" pitchFamily="34" charset="-120"/>
               </a:rPr>
-              <a:t>本週結論：Phase 0 有實作成果，但 Gate 尚未正式關閉</a:t>
+              <a:t>本週結論：Phase 1 已有前置實作成果，但 Gate 尚未正式關閉</a:t>
             </a:r>
             <a:endParaRPr lang="en-US" sz="1100" dirty="0"/>
           </a:p>
@@ -2185,7 +2185,7 @@
                 <a:ea typeface="Microsoft JhengHei" pitchFamily="34" charset="-122"/>
                 <a:cs typeface="Microsoft JhengHei" pitchFamily="34" charset="-120"/>
               </a:rPr>
-              <a:t>Phase 1～5 尚無實作證據</a:t>
+              <a:t>01_AI_KM_Phase規劃_v2.6.xlsx</a:t>
             </a:r>
             <a:endParaRPr lang="en-US" sz="1300" dirty="0"/>
           </a:p>
@@ -2278,7 +2278,7 @@
                 <a:ea typeface="Microsoft JhengHei" pitchFamily="34" charset="-122"/>
                 <a:cs typeface="Microsoft JhengHei" pitchFamily="34" charset="-120"/>
               </a:rPr>
-              <a:t>Phase 0</a:t>
+              <a:t>Phase 1</a:t>
             </a:r>
             <a:endParaRPr lang="en-US" sz="1600" dirty="0"/>
           </a:p>
@@ -2319,7 +2319,7 @@
                 <a:ea typeface="Microsoft JhengHei" pitchFamily="34" charset="-122"/>
                 <a:cs typeface="Microsoft JhengHei" pitchFamily="34" charset="-120"/>
               </a:rPr>
-              <a:t>84.5%</a:t>
+              <a:t>18.8%</a:t>
             </a:r>
             <a:endParaRPr lang="en-US" sz="1300" dirty="0"/>
           </a:p>
@@ -2470,7 +2470,7 @@
                 <a:ea typeface="Microsoft JhengHei" pitchFamily="34" charset="-122"/>
                 <a:cs typeface="Microsoft JhengHei" pitchFamily="34" charset="-120"/>
               </a:rPr>
-              <a:t>WP0 CI overall failure</a:t>
+              <a:t>v2.6 原始 Excel 尚未存在於 Git，規劃來源 Gate 阻塞</a:t>
             </a:r>
             <a:endParaRPr lang="en-US" sz="1300" dirty="0"/>
           </a:p>
@@ -2487,7 +2487,7 @@
                 <a:ea typeface="Microsoft JhengHei" pitchFamily="34" charset="-122"/>
                 <a:cs typeface="Microsoft JhengHei" pitchFamily="34" charset="-120"/>
               </a:rPr>
-              <a:t>WP1 尚無 PR／Review／Merge</a:t>
+              <a:t>WP0 CI 因 shallow checkout 失敗，需以新 run 驗證修正</a:t>
             </a:r>
             <a:endParaRPr lang="en-US" sz="1300" dirty="0"/>
           </a:p>
@@ -2529,7 +2529,7 @@
                 <a:ea typeface="Microsoft JhengHei" pitchFamily="34" charset="-122"/>
                 <a:cs typeface="Microsoft JhengHei" pitchFamily="34" charset="-120"/>
               </a:rPr>
-              <a:t>完成 Phase 0 實作證據盤點與保守計分</a:t>
+              <a:t>v2.6 取代舊版 Phase 規劃並鎖定 Anderson／Patty 責任切線</a:t>
             </a:r>
             <a:endParaRPr lang="en-US" sz="1600" dirty="0"/>
           </a:p>
@@ -2583,7 +2583,7 @@
                 <a:ea typeface="Microsoft JhengHei" pitchFamily="34" charset="-122"/>
                 <a:cs typeface="Microsoft JhengHei" pitchFamily="34" charset="-120"/>
               </a:rPr>
-              <a:t>Phase 1～5 與 WP0～WP13 規劃完成；WP10 拆為 WP10A、WP10B</a:t>
+              <a:t>設備預約與驗證申請入口納入 Phase 1；Benchmark 基礎移至 Phase 2</a:t>
             </a:r>
             <a:endParaRPr lang="en-US" sz="1600" dirty="0"/>
           </a:p>
@@ -2697,7 +2697,7 @@
                 <a:ea typeface="Microsoft JhengHei" pitchFamily="34" charset="-122"/>
                 <a:cs typeface="Microsoft JhengHei" pitchFamily="34" charset="-120"/>
               </a:rPr>
-              <a:t>Phase 0～5 總進度</a:t>
+              <a:t>Phase 1～5 總進度</a:t>
             </a:r>
             <a:endParaRPr lang="en-US" sz="2500" dirty="0"/>
           </a:p>
@@ -2779,7 +2779,7 @@
                 <a:ea typeface="Microsoft JhengHei" pitchFamily="34" charset="-122"/>
                 <a:cs typeface="Microsoft JhengHei" pitchFamily="34" charset="-120"/>
               </a:rPr>
-              <a:t>Phase 0 正式化基座</a:t>
+              <a:t>Phase 1 AI KM MVP</a:t>
             </a:r>
             <a:endParaRPr lang="en-US" sz="1300" dirty="0"/>
           </a:p>
@@ -2819,7 +2819,7 @@
         <p:spPr>
           <a:xfrm>
             <a:off x="2697480" y="1444752"/>
-            <a:ext cx="6760845" cy="164592"/>
+            <a:ext cx="1504188" cy="164592"/>
           </a:xfrm>
           <a:prstGeom prst="rect">
             <a:avLst/>
@@ -2868,7 +2868,7 @@
                 <a:ea typeface="Aptos" pitchFamily="34" charset="-122"/>
                 <a:cs typeface="Aptos" pitchFamily="34" charset="-120"/>
               </a:rPr>
-              <a:t>84.5%</a:t>
+              <a:t>18.8%</a:t>
             </a:r>
             <a:endParaRPr lang="en-US" sz="1300" dirty="0"/>
           </a:p>
@@ -2882,7 +2882,7 @@
         </p:nvSpPr>
         <p:spPr>
           <a:xfrm>
-            <a:off x="822960" y="2084832"/>
+            <a:off x="822960" y="2167128"/>
             <a:ext cx="1828800" cy="256032"/>
           </a:xfrm>
           <a:prstGeom prst="rect">
@@ -2909,7 +2909,7 @@
                 <a:ea typeface="Microsoft JhengHei" pitchFamily="34" charset="-122"/>
                 <a:cs typeface="Microsoft JhengHei" pitchFamily="34" charset="-120"/>
               </a:rPr>
-              <a:t>Phase 1 Production-ready MVP</a:t>
+              <a:t>Phase 2 Compile-Time RAG</a:t>
             </a:r>
             <a:endParaRPr lang="en-US" sz="1300" dirty="0"/>
           </a:p>
@@ -2923,7 +2923,7 @@
         </p:nvSpPr>
         <p:spPr>
           <a:xfrm>
-            <a:off x="2697480" y="2112264"/>
+            <a:off x="2697480" y="2194560"/>
             <a:ext cx="8001000" cy="164592"/>
           </a:xfrm>
           <a:prstGeom prst="rect">
@@ -2948,7 +2948,7 @@
         </p:nvSpPr>
         <p:spPr>
           <a:xfrm>
-            <a:off x="10771632" y="2057400"/>
+            <a:off x="10771632" y="2139696"/>
             <a:ext cx="548640" cy="256032"/>
           </a:xfrm>
           <a:prstGeom prst="rect">
@@ -2987,7 +2987,7 @@
         </p:nvSpPr>
         <p:spPr>
           <a:xfrm>
-            <a:off x="822960" y="2752344"/>
+            <a:off x="822960" y="2916936"/>
             <a:ext cx="1828800" cy="256032"/>
           </a:xfrm>
           <a:prstGeom prst="rect">
@@ -3014,7 +3014,7 @@
                 <a:ea typeface="Microsoft JhengHei" pitchFamily="34" charset="-122"/>
                 <a:cs typeface="Microsoft JhengHei" pitchFamily="34" charset="-120"/>
               </a:rPr>
-              <a:t>Phase 2 Compile-Time RAG</a:t>
+              <a:t>Phase 3 Agentic RAG</a:t>
             </a:r>
             <a:endParaRPr lang="en-US" sz="1300" dirty="0"/>
           </a:p>
@@ -3028,7 +3028,7 @@
         </p:nvSpPr>
         <p:spPr>
           <a:xfrm>
-            <a:off x="2697480" y="2779776"/>
+            <a:off x="2697480" y="2944368"/>
             <a:ext cx="8001000" cy="164592"/>
           </a:xfrm>
           <a:prstGeom prst="rect">
@@ -3053,7 +3053,7 @@
         </p:nvSpPr>
         <p:spPr>
           <a:xfrm>
-            <a:off x="10771632" y="2724912"/>
+            <a:off x="10771632" y="2889504"/>
             <a:ext cx="548640" cy="256032"/>
           </a:xfrm>
           <a:prstGeom prst="rect">
@@ -3092,7 +3092,7 @@
         </p:nvSpPr>
         <p:spPr>
           <a:xfrm>
-            <a:off x="822960" y="3419856"/>
+            <a:off x="822960" y="3666744"/>
             <a:ext cx="1828800" cy="256032"/>
           </a:xfrm>
           <a:prstGeom prst="rect">
@@ -3119,7 +3119,7 @@
                 <a:ea typeface="Microsoft JhengHei" pitchFamily="34" charset="-122"/>
                 <a:cs typeface="Microsoft JhengHei" pitchFamily="34" charset="-120"/>
               </a:rPr>
-              <a:t>Phase 3 Agentic RAG</a:t>
+              <a:t>Phase 4 AI Analysis</a:t>
             </a:r>
             <a:endParaRPr lang="en-US" sz="1300" dirty="0"/>
           </a:p>
@@ -3133,7 +3133,7 @@
         </p:nvSpPr>
         <p:spPr>
           <a:xfrm>
-            <a:off x="2697480" y="3447288"/>
+            <a:off x="2697480" y="3694176"/>
             <a:ext cx="8001000" cy="164592"/>
           </a:xfrm>
           <a:prstGeom prst="rect">
@@ -3158,7 +3158,7 @@
         </p:nvSpPr>
         <p:spPr>
           <a:xfrm>
-            <a:off x="10771632" y="3392424"/>
+            <a:off x="10771632" y="3639312"/>
             <a:ext cx="548640" cy="256032"/>
           </a:xfrm>
           <a:prstGeom prst="rect">
@@ -3197,7 +3197,7 @@
         </p:nvSpPr>
         <p:spPr>
           <a:xfrm>
-            <a:off x="822960" y="4087368"/>
+            <a:off x="822960" y="4416552"/>
             <a:ext cx="1828800" cy="256032"/>
           </a:xfrm>
           <a:prstGeom prst="rect">
@@ -3224,7 +3224,7 @@
                 <a:ea typeface="Microsoft JhengHei" pitchFamily="34" charset="-122"/>
                 <a:cs typeface="Microsoft JhengHei" pitchFamily="34" charset="-120"/>
               </a:rPr>
-              <a:t>Phase 4 AI Analysis</a:t>
+              <a:t>Phase 5 Enterprise Evolution</a:t>
             </a:r>
             <a:endParaRPr lang="en-US" sz="1300" dirty="0"/>
           </a:p>
@@ -3238,7 +3238,7 @@
         </p:nvSpPr>
         <p:spPr>
           <a:xfrm>
-            <a:off x="2697480" y="4114800"/>
+            <a:off x="2697480" y="4443984"/>
             <a:ext cx="8001000" cy="164592"/>
           </a:xfrm>
           <a:prstGeom prst="rect">
@@ -3263,7 +3263,7 @@
         </p:nvSpPr>
         <p:spPr>
           <a:xfrm>
-            <a:off x="10771632" y="4059936"/>
+            <a:off x="10771632" y="4389120"/>
             <a:ext cx="548640" cy="256032"/>
           </a:xfrm>
           <a:prstGeom prst="rect">
@@ -3297,111 +3297,6 @@
       <p:sp>
         <p:nvSpPr>
           <p:cNvPr id="20" name="Text 18"/>
-          <p:cNvSpPr/>
-          <p:nvPr/>
-        </p:nvSpPr>
-        <p:spPr>
-          <a:xfrm>
-            <a:off x="822960" y="4754880"/>
-            <a:ext cx="1828800" cy="256032"/>
-          </a:xfrm>
-          <a:prstGeom prst="rect">
-            <a:avLst/>
-          </a:prstGeom>
-          <a:noFill/>
-          <a:ln/>
-        </p:spPr>
-        <p:txBody>
-          <a:bodyPr wrap="square" lIns="0" tIns="0" rIns="0" bIns="0" rtlCol="0" anchor="ctr">
-            <a:normAutofit/>
-          </a:bodyPr>
-          <a:lstStyle/>
-          <a:p>
-            <a:pPr indent="0" marL="0">
-              <a:buNone/>
-            </a:pPr>
-            <a:r>
-              <a:rPr lang="en-US" sz="1300" b="1" dirty="0">
-                <a:solidFill>
-                  <a:srgbClr val="26333D"/>
-                </a:solidFill>
-                <a:latin typeface="Microsoft JhengHei" pitchFamily="34" charset="0"/>
-                <a:ea typeface="Microsoft JhengHei" pitchFamily="34" charset="-122"/>
-                <a:cs typeface="Microsoft JhengHei" pitchFamily="34" charset="-120"/>
-              </a:rPr>
-              <a:t>Phase 5 Enterprise Evolution</a:t>
-            </a:r>
-            <a:endParaRPr lang="en-US" sz="1300" dirty="0"/>
-          </a:p>
-        </p:txBody>
-      </p:sp>
-      <p:sp>
-        <p:nvSpPr>
-          <p:cNvPr id="21" name="Shape 19"/>
-          <p:cNvSpPr/>
-          <p:nvPr/>
-        </p:nvSpPr>
-        <p:spPr>
-          <a:xfrm>
-            <a:off x="2697480" y="4782312"/>
-            <a:ext cx="8001000" cy="164592"/>
-          </a:xfrm>
-          <a:prstGeom prst="rect">
-            <a:avLst/>
-          </a:prstGeom>
-          <a:solidFill>
-            <a:srgbClr val="E4EAED"/>
-          </a:solidFill>
-          <a:ln w="12700">
-            <a:solidFill>
-              <a:srgbClr val="E4EAED"/>
-            </a:solidFill>
-            <a:prstDash val="solid"/>
-          </a:ln>
-        </p:spPr>
-      </p:sp>
-      <p:sp>
-        <p:nvSpPr>
-          <p:cNvPr id="22" name="Text 20"/>
-          <p:cNvSpPr/>
-          <p:nvPr/>
-        </p:nvSpPr>
-        <p:spPr>
-          <a:xfrm>
-            <a:off x="10771632" y="4727448"/>
-            <a:ext cx="548640" cy="256032"/>
-          </a:xfrm>
-          <a:prstGeom prst="rect">
-            <a:avLst/>
-          </a:prstGeom>
-          <a:noFill/>
-          <a:ln/>
-        </p:spPr>
-        <p:txBody>
-          <a:bodyPr wrap="square" lIns="0" tIns="0" rIns="0" bIns="0" rtlCol="0" anchor="ctr"/>
-          <a:lstStyle/>
-          <a:p>
-            <a:pPr algn="r" indent="0" marL="0">
-              <a:buNone/>
-            </a:pPr>
-            <a:r>
-              <a:rPr lang="en-US" sz="1300" b="1" dirty="0">
-                <a:solidFill>
-                  <a:srgbClr val="667783"/>
-                </a:solidFill>
-                <a:latin typeface="Aptos" pitchFamily="34" charset="0"/>
-                <a:ea typeface="Aptos" pitchFamily="34" charset="-122"/>
-                <a:cs typeface="Aptos" pitchFamily="34" charset="-120"/>
-              </a:rPr>
-              <a:t>0%</a:t>
-            </a:r>
-            <a:endParaRPr lang="en-US" sz="1300" dirty="0"/>
-          </a:p>
-        </p:txBody>
-      </p:sp>
-      <p:sp>
-        <p:nvSpPr>
-          <p:cNvPr id="23" name="Text 21"/>
           <p:cNvSpPr/>
           <p:nvPr/>
         </p:nvSpPr>
@@ -3721,7 +3616,7 @@
                 <a:ea typeface="Microsoft JhengHei" pitchFamily="34" charset="-122"/>
                 <a:cs typeface="Microsoft JhengHei" pitchFamily="34" charset="-120"/>
               </a:rPr>
-              <a:t>FastAPI contract 與測試基線</a:t>
+              <a:t>FastAPI／REST API 與測試基線</a:t>
             </a:r>
             <a:endParaRPr lang="en-US" sz="1300" dirty="0"/>
           </a:p>
@@ -3789,7 +3684,7 @@
                 <a:ea typeface="Microsoft JhengHei" pitchFamily="34" charset="-122"/>
                 <a:cs typeface="Microsoft JhengHei" pitchFamily="34" charset="-120"/>
               </a:rPr>
-              <a:t>• hygiene whitespace failure</a:t>
+              <a:t>• hygiene shallow checkout failure</a:t>
             </a:r>
             <a:endParaRPr lang="en-US" sz="1300" dirty="0"/>
           </a:p>
@@ -3923,7 +3818,7 @@
                 <a:ea typeface="Microsoft JhengHei" pitchFamily="34" charset="-122"/>
                 <a:cs typeface="Microsoft JhengHei" pitchFamily="34" charset="-120"/>
               </a:rPr>
-              <a:t>Job/config reliability</a:t>
+              <a:t>Docker／Redis／Celery／環境正式化</a:t>
             </a:r>
             <a:endParaRPr lang="en-US" sz="1300" dirty="0"/>
           </a:p>
@@ -4030,7 +3925,7 @@
                 <a:ea typeface="Microsoft JhengHei" pitchFamily="34" charset="-122"/>
                 <a:cs typeface="Microsoft JhengHei" pitchFamily="34" charset="-120"/>
               </a:rPr>
-              <a:t>WP2～WP13：0%｜無實作證據，標示尚未開始</a:t>
+              <a:t>WP2～WP13：0%｜依 v2.6 新 WP 對應，無實作證據</a:t>
             </a:r>
             <a:endParaRPr lang="en-US" sz="1900" dirty="0"/>
           </a:p>
@@ -4319,7 +4214,7 @@
                 <a:ea typeface="Microsoft JhengHei" pitchFamily="34" charset="-122"/>
                 <a:cs typeface="Microsoft JhengHei" pitchFamily="34" charset="-120"/>
               </a:rPr>
-              <a:t>WP0 whitespace CI failure；PR 無 review/merge</a:t>
+              <a:t>WP0 hygiene shallow checkout failure；PR 無 review/merge</a:t>
             </a:r>
             <a:endParaRPr lang="en-US" sz="1300" dirty="0"/>
           </a:p>
@@ -4876,7 +4771,7 @@
                 <a:ea typeface="Microsoft JhengHei" pitchFamily="34" charset="-122"/>
                 <a:cs typeface="Microsoft JhengHei" pitchFamily="34" charset="-120"/>
               </a:rPr>
-              <a:t>1. WP0 CI 整體失敗，不能關閉 G0</a:t>
+              <a:t>1. v2.6 原始 Excel 尚未存在於 Git，規劃來源 Gate 阻塞</a:t>
             </a:r>
             <a:endParaRPr lang="en-US" sz="1300" dirty="0"/>
           </a:p>
@@ -4899,7 +4794,7 @@
                 <a:ea typeface="Microsoft JhengHei" pitchFamily="34" charset="-122"/>
                 <a:cs typeface="Microsoft JhengHei" pitchFamily="34" charset="-120"/>
               </a:rPr>
-              <a:t>2. WP1 無 PR，變更尚未進入正式 review</a:t>
+              <a:t>2. WP0 CI 因 shallow checkout 失敗，需以新 run 驗證修正</a:t>
             </a:r>
             <a:endParaRPr lang="en-US" sz="1300" dirty="0"/>
           </a:p>
@@ -4922,7 +4817,30 @@
                 <a:ea typeface="Microsoft JhengHei" pitchFamily="34" charset="-122"/>
                 <a:cs typeface="Microsoft JhengHei" pitchFamily="34" charset="-120"/>
               </a:rPr>
-              <a:t>3. 正式環境 backup/restore 與長時間故障注入尚未驗證</a:t>
+              <a:t>3. WP1 無 PR，尚未進入正式 review</a:t>
+            </a:r>
+            <a:endParaRPr lang="en-US" sz="1300" dirty="0"/>
+          </a:p>
+          <a:p>
+            <a:pPr indent="0" marL="0">
+              <a:buNone/>
+            </a:pPr>
+            <a:endParaRPr lang="en-US" sz="1300" dirty="0"/>
+          </a:p>
+          <a:p>
+            <a:pPr indent="0" marL="0">
+              <a:buNone/>
+            </a:pPr>
+            <a:r>
+              <a:rPr lang="en-US" sz="1300" dirty="0">
+                <a:solidFill>
+                  <a:srgbClr val="26333D"/>
+                </a:solidFill>
+                <a:latin typeface="Microsoft JhengHei" pitchFamily="34" charset="0"/>
+                <a:ea typeface="Microsoft JhengHei" pitchFamily="34" charset="-122"/>
+                <a:cs typeface="Microsoft JhengHei" pitchFamily="34" charset="-120"/>
+              </a:rPr>
+              <a:t>4. WP2 依賴 CSIT API、Booking、Validation Request Contract；Anderson 不得猜測</a:t>
             </a:r>
             <a:endParaRPr lang="en-US" sz="1300" dirty="0"/>
           </a:p>
@@ -5056,7 +4974,7 @@
                 <a:ea typeface="Microsoft JhengHei" pitchFamily="34" charset="-122"/>
                 <a:cs typeface="Microsoft JhengHei" pitchFamily="34" charset="-120"/>
               </a:rPr>
-              <a:t>1. 是否要求 WP0 修正 whitespace 後才允許 WP1 PR review</a:t>
+              <a:t>1. 由規劃 Owner 提供並核對 v2.6 原始 Excel</a:t>
             </a:r>
             <a:endParaRPr lang="en-US" sz="1300" dirty="0"/>
           </a:p>
@@ -5079,7 +4997,7 @@
                 <a:ea typeface="Microsoft JhengHei" pitchFamily="34" charset="-122"/>
                 <a:cs typeface="Microsoft JhengHei" pitchFamily="34" charset="-120"/>
               </a:rPr>
-              <a:t>2. 確認 WP1 PR 的 reviewer 與 merge gate owner</a:t>
+              <a:t>2. 確認 WP0 修正與 merge gate owner</a:t>
             </a:r>
             <a:endParaRPr lang="en-US" sz="1300" dirty="0"/>
           </a:p>
@@ -5102,7 +5020,30 @@
                 <a:ea typeface="Microsoft JhengHei" pitchFamily="34" charset="-122"/>
                 <a:cs typeface="Microsoft JhengHei" pitchFamily="34" charset="-120"/>
               </a:rPr>
-              <a:t>3. 確認 Phase 1 CSIT API/ACL 未決事項 owner</a:t>
+              <a:t>3. 確認 WP1 reviewer 與 PR 時程</a:t>
+            </a:r>
+            <a:endParaRPr lang="en-US" sz="1300" dirty="0"/>
+          </a:p>
+          <a:p>
+            <a:pPr indent="0" marL="0">
+              <a:buNone/>
+            </a:pPr>
+            <a:endParaRPr lang="en-US" sz="1300" dirty="0"/>
+          </a:p>
+          <a:p>
+            <a:pPr indent="0" marL="0">
+              <a:buNone/>
+            </a:pPr>
+            <a:r>
+              <a:rPr lang="en-US" sz="1300" dirty="0">
+                <a:solidFill>
+                  <a:srgbClr val="26333D"/>
+                </a:solidFill>
+                <a:latin typeface="Microsoft JhengHei" pitchFamily="34" charset="0"/>
+                <a:ea typeface="Microsoft JhengHei" pitchFamily="34" charset="-122"/>
+                <a:cs typeface="Microsoft JhengHei" pitchFamily="34" charset="-120"/>
+              </a:rPr>
+              <a:t>4. 由 Patty 提供 WP2 的 CSIT API／Booking／Validation Request Contract</a:t>
             </a:r>
             <a:endParaRPr lang="en-US" sz="1300" dirty="0"/>
           </a:p>
@@ -5467,7 +5408,7 @@
                 <a:ea typeface="Microsoft JhengHei" pitchFamily="34" charset="-122"/>
                 <a:cs typeface="Microsoft JhengHei" pitchFamily="34" charset="-120"/>
               </a:rPr>
-              <a:t>建立並審查 WP1 PR，不直接合併 main/dev-work</a:t>
+              <a:t>建立並審查 WP1 PR</a:t>
             </a:r>
             <a:endParaRPr lang="en-US" sz="1800" dirty="0"/>
           </a:p>
@@ -5572,7 +5513,7 @@
                 <a:ea typeface="Microsoft JhengHei" pitchFamily="34" charset="-122"/>
                 <a:cs typeface="Microsoft JhengHei" pitchFamily="34" charset="-120"/>
               </a:rPr>
-              <a:t>啟動 WP2 Knowledge Package contract，先完成 schema 與 negative tests</a:t>
+              <a:t>取得 Contract 後啟動 WP2 Client／Adapter 與兩項入口；未取得時只做 fake adapter／contract test</a:t>
             </a:r>
             <a:endParaRPr lang="en-US" sz="1800" dirty="0"/>
           </a:p>

</xml_diff>

<commit_message>
docs: record green WP0 and WP1 acceptance CI
</commit_message>
<xml_diff>
--- a/docs/km-modernization/progress/presentations/AI-KM-Weekly-2026-W33.pptx
+++ b/docs/km-modernization/progress/presentations/AI-KM-Weekly-2026-W33.pptx
@@ -1840,7 +1840,7 @@
                 <a:ea typeface="Microsoft JhengHei" pitchFamily="34" charset="-122"/>
                 <a:cs typeface="Microsoft JhengHei" pitchFamily="34" charset="-120"/>
               </a:rPr>
-              <a:t>全計畫 11.3%</a:t>
+              <a:t>全計畫 11.5%</a:t>
             </a:r>
             <a:endParaRPr lang="en-US" sz="2400" dirty="0"/>
           </a:p>
@@ -2168,7 +2168,7 @@
                 <a:ea typeface="Microsoft JhengHei" pitchFamily="34" charset="-122"/>
                 <a:cs typeface="Microsoft JhengHei" pitchFamily="34" charset="-120"/>
               </a:rPr>
-              <a:t>11.3%</a:t>
+              <a:t>11.5%</a:t>
             </a:r>
             <a:endParaRPr lang="en-US" sz="1300" dirty="0"/>
           </a:p>
@@ -2319,7 +2319,7 @@
                 <a:ea typeface="Microsoft JhengHei" pitchFamily="34" charset="-122"/>
                 <a:cs typeface="Microsoft JhengHei" pitchFamily="34" charset="-120"/>
               </a:rPr>
-              <a:t>18.8%</a:t>
+              <a:t>19.1%</a:t>
             </a:r>
             <a:endParaRPr lang="en-US" sz="1300" dirty="0"/>
           </a:p>
@@ -2336,7 +2336,7 @@
                 <a:ea typeface="Microsoft JhengHei" pitchFamily="34" charset="-122"/>
                 <a:cs typeface="Microsoft JhengHei" pitchFamily="34" charset="-120"/>
               </a:rPr>
-              <a:t>WP0 82%｜WP1 87%</a:t>
+              <a:t>WP0 85%｜WP1 87%</a:t>
             </a:r>
             <a:endParaRPr lang="en-US" sz="1300" dirty="0"/>
           </a:p>
@@ -2487,7 +2487,7 @@
                 <a:ea typeface="Microsoft JhengHei" pitchFamily="34" charset="-122"/>
                 <a:cs typeface="Microsoft JhengHei" pitchFamily="34" charset="-120"/>
               </a:rPr>
-              <a:t>WP0 CI 因 shallow checkout 失敗，需以新 run 驗證修正</a:t>
+              <a:t>WP0 無 review／merge 與正式入口 E2E artifact</a:t>
             </a:r>
             <a:endParaRPr lang="en-US" sz="1300" dirty="0"/>
           </a:p>
@@ -2547,7 +2547,7 @@
                 <a:ea typeface="Microsoft JhengHei" pitchFamily="34" charset="-122"/>
                 <a:cs typeface="Microsoft JhengHei" pitchFamily="34" charset="-120"/>
               </a:rPr>
-              <a:t>WP0 PR #2 存在但 CI overall failure、無 review、未合併</a:t>
+              <a:t>WP0／WP1 驗收分支 CI 六個 job 全部成功</a:t>
             </a:r>
             <a:endParaRPr lang="en-US" sz="1600" dirty="0"/>
           </a:p>
@@ -2565,7 +2565,7 @@
                 <a:ea typeface="Microsoft JhengHei" pitchFamily="34" charset="-122"/>
                 <a:cs typeface="Microsoft JhengHei" pitchFamily="34" charset="-120"/>
               </a:rPr>
-              <a:t>WP1 CI 三個 job 成功，但無 PR、review 或 merge</a:t>
+              <a:t>WP0 PR #2 無 review／merge；WP1 仍無 PR</a:t>
             </a:r>
             <a:endParaRPr lang="en-US" sz="1600" dirty="0"/>
           </a:p>
@@ -2819,7 +2819,7 @@
         <p:spPr>
           <a:xfrm>
             <a:off x="2697480" y="1444752"/>
-            <a:ext cx="1504188" cy="164592"/>
+            <a:ext cx="1528191" cy="164592"/>
           </a:xfrm>
           <a:prstGeom prst="rect">
             <a:avLst/>
@@ -2868,7 +2868,7 @@
                 <a:ea typeface="Aptos" pitchFamily="34" charset="-122"/>
                 <a:cs typeface="Aptos" pitchFamily="34" charset="-120"/>
               </a:rPr>
-              <a:t>18.8%</a:t>
+              <a:t>19.1%</a:t>
             </a:r>
             <a:endParaRPr lang="en-US" sz="1300" dirty="0"/>
           </a:p>
@@ -3327,7 +3327,7 @@
                 <a:ea typeface="Microsoft JhengHei" pitchFamily="34" charset="-122"/>
                 <a:cs typeface="Microsoft JhengHei" pitchFamily="34" charset="-120"/>
               </a:rPr>
-              <a:t>全計畫進度 11.3%（15 個 WP 等權平均）</a:t>
+              <a:t>全計畫進度 11.5%（15 個 WP 等權平均）</a:t>
             </a:r>
             <a:endParaRPr lang="en-US" sz="1800" dirty="0"/>
           </a:p>
@@ -3575,7 +3575,7 @@
                 <a:ea typeface="Microsoft JhengHei" pitchFamily="34" charset="-122"/>
                 <a:cs typeface="Microsoft JhengHei" pitchFamily="34" charset="-120"/>
               </a:rPr>
-              <a:t>WP0｜82%</a:t>
+              <a:t>WP0｜85%</a:t>
             </a:r>
             <a:endParaRPr lang="en-US" sz="1600" dirty="0"/>
           </a:p>
@@ -3667,7 +3667,7 @@
                 <a:ea typeface="Microsoft JhengHei" pitchFamily="34" charset="-122"/>
                 <a:cs typeface="Microsoft JhengHei" pitchFamily="34" charset="-120"/>
               </a:rPr>
-              <a:t>• backend、frontend 成功</a:t>
+              <a:t>• 驗收分支 WP0 CI 三個 job 成功</a:t>
             </a:r>
             <a:endParaRPr lang="en-US" sz="1300" dirty="0"/>
           </a:p>
@@ -3684,7 +3684,7 @@
                 <a:ea typeface="Microsoft JhengHei" pitchFamily="34" charset="-122"/>
                 <a:cs typeface="Microsoft JhengHei" pitchFamily="34" charset="-120"/>
               </a:rPr>
-              <a:t>• hygiene shallow checkout failure</a:t>
+              <a:t>• 正式入口 E2E 尚缺 artifact</a:t>
             </a:r>
             <a:endParaRPr lang="en-US" sz="1300" dirty="0"/>
           </a:p>
@@ -4128,11 +4128,11 @@
             <a:avLst/>
           </a:prstGeom>
           <a:solidFill>
-            <a:srgbClr val="A83B3B"/>
+            <a:srgbClr val="B16D00"/>
           </a:solidFill>
           <a:ln w="12700">
             <a:solidFill>
-              <a:srgbClr val="A83B3B"/>
+              <a:srgbClr val="B16D00"/>
             </a:solidFill>
             <a:prstDash val="solid"/>
           </a:ln>
@@ -4167,13 +4167,13 @@
             <a:r>
               <a:rPr lang="en-US" sz="1600" b="1" dirty="0">
                 <a:solidFill>
-                  <a:srgbClr val="A83B3B"/>
-                </a:solidFill>
-                <a:latin typeface="Microsoft JhengHei" pitchFamily="34" charset="0"/>
-                <a:ea typeface="Microsoft JhengHei" pitchFamily="34" charset="-122"/>
-                <a:cs typeface="Microsoft JhengHei" pitchFamily="34" charset="-120"/>
-              </a:rPr>
-              <a:t>G0 API baseline｜阻塞</a:t>
+                  <a:srgbClr val="B16D00"/>
+                </a:solidFill>
+                <a:latin typeface="Microsoft JhengHei" pitchFamily="34" charset="0"/>
+                <a:ea typeface="Microsoft JhengHei" pitchFamily="34" charset="-122"/>
+                <a:cs typeface="Microsoft JhengHei" pitchFamily="34" charset="-120"/>
+              </a:rPr>
+              <a:t>G0 API baseline｜條件通過</a:t>
             </a:r>
             <a:endParaRPr lang="en-US" sz="1600" dirty="0"/>
           </a:p>
@@ -4214,7 +4214,7 @@
                 <a:ea typeface="Microsoft JhengHei" pitchFamily="34" charset="-122"/>
                 <a:cs typeface="Microsoft JhengHei" pitchFamily="34" charset="-120"/>
               </a:rPr>
-              <a:t>WP0 hygiene shallow checkout failure；PR 無 review/merge</a:t>
+              <a:t>驗收分支 CI green；缺 PR review/merge 與正式入口 E2E artifact</a:t>
             </a:r>
             <a:endParaRPr lang="en-US" sz="1300" dirty="0"/>
           </a:p>
@@ -4794,7 +4794,7 @@
                 <a:ea typeface="Microsoft JhengHei" pitchFamily="34" charset="-122"/>
                 <a:cs typeface="Microsoft JhengHei" pitchFamily="34" charset="-120"/>
               </a:rPr>
-              <a:t>2. WP0 CI 因 shallow checkout 失敗，需以新 run 驗證修正</a:t>
+              <a:t>2. WP0 無 review／merge 與正式入口 E2E artifact</a:t>
             </a:r>
             <a:endParaRPr lang="en-US" sz="1300" dirty="0"/>
           </a:p>
@@ -5303,7 +5303,7 @@
                 <a:ea typeface="Microsoft JhengHei" pitchFamily="34" charset="-122"/>
                 <a:cs typeface="Microsoft JhengHei" pitchFamily="34" charset="-120"/>
               </a:rPr>
-              <a:t>修正 WP0 repository-hygiene 並重跑 CI</a:t>
+              <a:t>完成 WP0 review／merge 與正式入口 E2E artifact</a:t>
             </a:r>
             <a:endParaRPr lang="en-US" sz="1800" dirty="0"/>
           </a:p>
@@ -5513,7 +5513,7 @@
                 <a:ea typeface="Microsoft JhengHei" pitchFamily="34" charset="-122"/>
                 <a:cs typeface="Microsoft JhengHei" pitchFamily="34" charset="-120"/>
               </a:rPr>
-              <a:t>取得 Contract 後啟動 WP2 Client／Adapter 與兩項入口；未取得時只做 fake adapter／contract test</a:t>
+              <a:t>取得 Contract 且前置 Gate 關閉後才啟動 WP2 Client／Adapter 與兩項入口；未取得時只做 fake adapter／contract test</a:t>
             </a:r>
             <a:endParaRPr lang="en-US" sz="1800" dirty="0"/>
           </a:p>

</xml_diff>

<commit_message>
docs: preserve v2.6 source package for supervisor review
</commit_message>
<xml_diff>
--- a/docs/km-modernization/progress/presentations/AI-KM-Weekly-2026-W33.pptx
+++ b/docs/km-modernization/progress/presentations/AI-KM-Weekly-2026-W33.pptx
@@ -2189,6 +2189,23 @@
             </a:r>
             <a:endParaRPr lang="en-US" sz="1300" dirty="0"/>
           </a:p>
+          <a:p>
+            <a:pPr indent="0" marL="0">
+              <a:buNone/>
+            </a:pPr>
+            <a:r>
+              <a:rPr lang="en-US" sz="1300" dirty="0">
+                <a:solidFill>
+                  <a:srgbClr val="26333D"/>
+                </a:solidFill>
+                <a:latin typeface="Microsoft JhengHei" pitchFamily="34" charset="0"/>
+                <a:ea typeface="Microsoft JhengHei" pitchFamily="34" charset="-122"/>
+                <a:cs typeface="Microsoft JhengHei" pitchFamily="34" charset="-120"/>
+              </a:rPr>
+              <a:t>來源：verified_in_git</a:t>
+            </a:r>
+            <a:endParaRPr lang="en-US" sz="1300" dirty="0"/>
+          </a:p>
         </p:txBody>
       </p:sp>
       <p:sp>
@@ -2470,7 +2487,7 @@
                 <a:ea typeface="Microsoft JhengHei" pitchFamily="34" charset="-122"/>
                 <a:cs typeface="Microsoft JhengHei" pitchFamily="34" charset="-120"/>
               </a:rPr>
-              <a:t>v2.6 原始 Excel 尚未存在於 Git，規劃來源 Gate 阻塞</a:t>
+              <a:t>WP0 無 review／merge 與正式入口 E2E artifact</a:t>
             </a:r>
             <a:endParaRPr lang="en-US" sz="1300" dirty="0"/>
           </a:p>
@@ -2487,7 +2504,7 @@
                 <a:ea typeface="Microsoft JhengHei" pitchFamily="34" charset="-122"/>
                 <a:cs typeface="Microsoft JhengHei" pitchFamily="34" charset="-120"/>
               </a:rPr>
-              <a:t>WP0 無 review／merge 與正式入口 E2E artifact</a:t>
+              <a:t>WP1 無 PR，尚未進入正式 review</a:t>
             </a:r>
             <a:endParaRPr lang="en-US" sz="1300" dirty="0"/>
           </a:p>
@@ -4771,7 +4788,7 @@
                 <a:ea typeface="Microsoft JhengHei" pitchFamily="34" charset="-122"/>
                 <a:cs typeface="Microsoft JhengHei" pitchFamily="34" charset="-120"/>
               </a:rPr>
-              <a:t>1. v2.6 原始 Excel 尚未存在於 Git，規劃來源 Gate 阻塞</a:t>
+              <a:t>1. WP0 無 review／merge 與正式入口 E2E artifact</a:t>
             </a:r>
             <a:endParaRPr lang="en-US" sz="1300" dirty="0"/>
           </a:p>
@@ -4794,7 +4811,7 @@
                 <a:ea typeface="Microsoft JhengHei" pitchFamily="34" charset="-122"/>
                 <a:cs typeface="Microsoft JhengHei" pitchFamily="34" charset="-120"/>
               </a:rPr>
-              <a:t>2. WP0 無 review／merge 與正式入口 E2E artifact</a:t>
+              <a:t>2. WP1 無 PR，尚未進入正式 review</a:t>
             </a:r>
             <a:endParaRPr lang="en-US" sz="1300" dirty="0"/>
           </a:p>
@@ -4817,7 +4834,7 @@
                 <a:ea typeface="Microsoft JhengHei" pitchFamily="34" charset="-122"/>
                 <a:cs typeface="Microsoft JhengHei" pitchFamily="34" charset="-120"/>
               </a:rPr>
-              <a:t>3. WP1 無 PR，尚未進入正式 review</a:t>
+              <a:t>3. WP2 依賴 CSIT API、Booking、Validation Request Contract；Anderson 不得猜測</a:t>
             </a:r>
             <a:endParaRPr lang="en-US" sz="1300" dirty="0"/>
           </a:p>
@@ -4840,7 +4857,7 @@
                 <a:ea typeface="Microsoft JhengHei" pitchFamily="34" charset="-122"/>
                 <a:cs typeface="Microsoft JhengHei" pitchFamily="34" charset="-120"/>
               </a:rPr>
-              <a:t>4. WP2 依賴 CSIT API、Booking、Validation Request Contract；Anderson 不得猜測</a:t>
+              <a:t>4. 原始規劃與技術規格已納入 Git，但仍需 Owner 確認其版本與責任邊界</a:t>
             </a:r>
             <a:endParaRPr lang="en-US" sz="1300" dirty="0"/>
           </a:p>
@@ -4974,7 +4991,7 @@
                 <a:ea typeface="Microsoft JhengHei" pitchFamily="34" charset="-122"/>
                 <a:cs typeface="Microsoft JhengHei" pitchFamily="34" charset="-120"/>
               </a:rPr>
-              <a:t>1. 由規劃 Owner 提供並核對 v2.6 原始 Excel</a:t>
+              <a:t>1. 由規劃 Owner 核對已納入 Git 的 v2.6 原始資料與 SHA-256</a:t>
             </a:r>
             <a:endParaRPr lang="en-US" sz="1300" dirty="0"/>
           </a:p>

</xml_diff>